<commit_message>
present(deck): rebuild the artifacts after the slide's wording fix
The .pptx and its PDF render come from the generator, never a hand patch, so
the wording change in the previous commit has to be rebuilt through it. 34
pages, the 0.6.1 slide among them.

Co-Authored-By: Claude Opus 5 <noreply@anthropic.com>
</commit_message>
<xml_diff>
--- a/present/ripwire-showcase.pptx
+++ b/present/ripwire-showcase.pptx
@@ -1264,7 +1264,7 @@
 IT SAYS WHAT IT COULD NOT PROVE
 - 89 of 4,322: #173. 'On ripwire's own tree, over every file:name selector whose selection is all declarations, the binary after #173 shrank 89 of 4,322 answers compared with the one before it, and grew none.' The population is the whole selector set, not a sample, which is why the claim can be one-directional.
 - The defect #173 fixed: the widening matched on the name and the enclosing scope, and that scope drops namespaces, so --callers=a/Store.h:putObject counted callB in b/Store.cpp, a caller of a DIFFERENT Store, and a free function matched on its name alone.
-- 9 verbs: #190, #195 — unproven_defs= on --callers, --callees, --impact, --safe-delete, --path, --uses, --mentions, --verify and --affected. 'all but the first two had answered from the declaration alone and printed a clean zero'.
+- nine listing verbs: #190, #195 — unproven_defs= on --callers, --callees, --impact, --safe-delete, --path, --uses, --mentions, --verify and --affected. 'all but the first two had answered from the declaration alone and printed a clean zero'.
 - incompatible="0": #210 — 'on every verb that resolves a focus symbol at all, --edit-check included, where an incompatible="0" beside unproven_defs= is now stated to be an incomplete read rather than a safe edit'.
 EVERY NUMBER CARRIES ITS DEFINITION
 - graph_unindexed=: #169 — shipped in 0.6.0 with no definition on --lego, --verify and --nonlocal-state, and under --legend=compact on every XML verb except --connect.
@@ -5646,7 +5646,7 @@
                 <a:ea typeface="Courier New" pitchFamily="34" charset="-122"/>
                 <a:cs typeface="Courier New" pitchFamily="34" charset="-120"/>
               </a:rPr>
-              <a:t>9 verbs</a:t>
+              <a:t>nine listing verbs</a:t>
             </a:r>
             <a:endParaRPr lang="en-US" sz="1300" dirty="0"/>
           </a:p>

</xml_diff>